<commit_message>
modified:   content/Assets/Self/Figures_Gamma-Camera.pptx 	modified:   content/Gamma Cameras, Classical and Solid State.md 	modified:   quartz.config.yaml
</commit_message>
<xml_diff>
--- a/content/Assets/Self/Figures_Gamma-Camera.pptx
+++ b/content/Assets/Self/Figures_Gamma-Camera.pptx
@@ -6,6 +6,7 @@
   </p:sldMasterIdLst>
   <p:sldIdLst>
     <p:sldId id="256" r:id="rId2"/>
+    <p:sldId id="257" r:id="rId3"/>
   </p:sldIdLst>
   <p:sldSz cx="12192000" cy="6858000"/>
   <p:notesSz cx="6858000" cy="9144000"/>
@@ -105,6 +106,83 @@
     </a:lvl9pPr>
   </p:defaultTextStyle>
 </p:presentation>
+</file>
+
+<file path=ppt/revisionInfo.xml><?xml version="1.0" encoding="utf-8"?>
+<p1510:revInfo xmlns:a="http://schemas.openxmlformats.org/drawingml/2006/main" xmlns:r="http://schemas.openxmlformats.org/officeDocument/2006/relationships" xmlns:p1510="http://schemas.microsoft.com/office/powerpoint/2015/10/main">
+  <p1510:revLst>
+    <p1510:client id="{F78C66EF-1635-4A56-83AD-9D087C169E7A}" v="3" dt="2026-07-07T10:33:30.594"/>
+  </p1510:revLst>
+</p1510:revInfo>
+</file>
+
+<file path=ppt/changesInfos/changesInfo1.xml><?xml version="1.0" encoding="utf-8"?>
+<pc:chgInfo xmlns:a="http://schemas.openxmlformats.org/drawingml/2006/main" xmlns:r="http://schemas.openxmlformats.org/officeDocument/2006/relationships" xmlns:ac="http://schemas.microsoft.com/office/drawing/2013/main/command" xmlns:pc="http://schemas.microsoft.com/office/powerpoint/2013/main/command">
+  <pc:docChgLst>
+    <pc:chgData name="BUNYAN, Jack (NHS HUMBER HEALTH PARTNERSHIP - RWA)" userId="cc86845f-be38-43df-904e-f1295fc07ff6" providerId="ADAL" clId="{203D993B-4EA0-4727-B616-4A4EDAEC11B2}"/>
+    <pc:docChg chg="custSel addSld modSld">
+      <pc:chgData name="BUNYAN, Jack (NHS HUMBER HEALTH PARTNERSHIP - RWA)" userId="cc86845f-be38-43df-904e-f1295fc07ff6" providerId="ADAL" clId="{203D993B-4EA0-4727-B616-4A4EDAEC11B2}" dt="2026-07-07T10:33:45.052" v="48" actId="1037"/>
+      <pc:docMkLst>
+        <pc:docMk/>
+      </pc:docMkLst>
+      <pc:sldChg chg="addSp delSp modSp new mod">
+        <pc:chgData name="BUNYAN, Jack (NHS HUMBER HEALTH PARTNERSHIP - RWA)" userId="cc86845f-be38-43df-904e-f1295fc07ff6" providerId="ADAL" clId="{203D993B-4EA0-4727-B616-4A4EDAEC11B2}" dt="2026-07-07T10:33:45.052" v="48" actId="1037"/>
+        <pc:sldMkLst>
+          <pc:docMk/>
+          <pc:sldMk cId="1809686048" sldId="257"/>
+        </pc:sldMkLst>
+        <pc:spChg chg="del">
+          <ac:chgData name="BUNYAN, Jack (NHS HUMBER HEALTH PARTNERSHIP - RWA)" userId="cc86845f-be38-43df-904e-f1295fc07ff6" providerId="ADAL" clId="{203D993B-4EA0-4727-B616-4A4EDAEC11B2}" dt="2026-07-07T10:32:33.383" v="1" actId="478"/>
+          <ac:spMkLst>
+            <pc:docMk/>
+            <pc:sldMk cId="1809686048" sldId="257"/>
+            <ac:spMk id="2" creationId="{54AEDC10-4871-D4FA-E201-E13D74C37031}"/>
+          </ac:spMkLst>
+        </pc:spChg>
+        <pc:spChg chg="del">
+          <ac:chgData name="BUNYAN, Jack (NHS HUMBER HEALTH PARTNERSHIP - RWA)" userId="cc86845f-be38-43df-904e-f1295fc07ff6" providerId="ADAL" clId="{203D993B-4EA0-4727-B616-4A4EDAEC11B2}" dt="2026-07-07T10:32:33.383" v="1" actId="478"/>
+          <ac:spMkLst>
+            <pc:docMk/>
+            <pc:sldMk cId="1809686048" sldId="257"/>
+            <ac:spMk id="3" creationId="{62003EFF-6254-33FE-2561-9DF4A736F209}"/>
+          </ac:spMkLst>
+        </pc:spChg>
+        <pc:cxnChg chg="add mod">
+          <ac:chgData name="BUNYAN, Jack (NHS HUMBER HEALTH PARTNERSHIP - RWA)" userId="cc86845f-be38-43df-904e-f1295fc07ff6" providerId="ADAL" clId="{203D993B-4EA0-4727-B616-4A4EDAEC11B2}" dt="2026-07-07T10:32:56.492" v="33" actId="1582"/>
+          <ac:cxnSpMkLst>
+            <pc:docMk/>
+            <pc:sldMk cId="1809686048" sldId="257"/>
+            <ac:cxnSpMk id="5" creationId="{3165D564-760F-C86C-A424-A32583C29A58}"/>
+          </ac:cxnSpMkLst>
+        </pc:cxnChg>
+        <pc:cxnChg chg="add mod">
+          <ac:chgData name="BUNYAN, Jack (NHS HUMBER HEALTH PARTNERSHIP - RWA)" userId="cc86845f-be38-43df-904e-f1295fc07ff6" providerId="ADAL" clId="{203D993B-4EA0-4727-B616-4A4EDAEC11B2}" dt="2026-07-07T10:33:45.052" v="48" actId="1037"/>
+          <ac:cxnSpMkLst>
+            <pc:docMk/>
+            <pc:sldMk cId="1809686048" sldId="257"/>
+            <ac:cxnSpMk id="6" creationId="{29D0C014-E233-FA34-6ADA-A1C326E969D7}"/>
+          </ac:cxnSpMkLst>
+        </pc:cxnChg>
+        <pc:cxnChg chg="add mod">
+          <ac:chgData name="BUNYAN, Jack (NHS HUMBER HEALTH PARTNERSHIP - RWA)" userId="cc86845f-be38-43df-904e-f1295fc07ff6" providerId="ADAL" clId="{203D993B-4EA0-4727-B616-4A4EDAEC11B2}" dt="2026-07-07T10:33:18.598" v="37" actId="1076"/>
+          <ac:cxnSpMkLst>
+            <pc:docMk/>
+            <pc:sldMk cId="1809686048" sldId="257"/>
+            <ac:cxnSpMk id="9" creationId="{18830C68-2501-0A9F-6D5B-709EB446BA2B}"/>
+          </ac:cxnSpMkLst>
+        </pc:cxnChg>
+        <pc:cxnChg chg="add mod">
+          <ac:chgData name="BUNYAN, Jack (NHS HUMBER HEALTH PARTNERSHIP - RWA)" userId="cc86845f-be38-43df-904e-f1295fc07ff6" providerId="ADAL" clId="{203D993B-4EA0-4727-B616-4A4EDAEC11B2}" dt="2026-07-07T10:33:21.753" v="39" actId="1076"/>
+          <ac:cxnSpMkLst>
+            <pc:docMk/>
+            <pc:sldMk cId="1809686048" sldId="257"/>
+            <ac:cxnSpMk id="10" creationId="{54C2CE58-B1B8-B487-F0AC-A7739467FD20}"/>
+          </ac:cxnSpMkLst>
+        </pc:cxnChg>
+      </pc:sldChg>
+    </pc:docChg>
+  </pc:docChgLst>
+</pc:chgInfo>
 </file>
 
 <file path=ppt/slideLayouts/slideLayout1.xml><?xml version="1.0" encoding="utf-8"?>
@@ -5360,6 +5438,191 @@
     <p:extLst>
       <p:ext uri="{BB962C8B-B14F-4D97-AF65-F5344CB8AC3E}">
         <p14:creationId xmlns:p14="http://schemas.microsoft.com/office/powerpoint/2010/main" val="1610676868"/>
+      </p:ext>
+    </p:extLst>
+  </p:cSld>
+  <p:clrMapOvr>
+    <a:masterClrMapping/>
+  </p:clrMapOvr>
+</p:sld>
+</file>
+
+<file path=ppt/slides/slide2.xml><?xml version="1.0" encoding="utf-8"?>
+<p:sld xmlns:a="http://schemas.openxmlformats.org/drawingml/2006/main" xmlns:r="http://schemas.openxmlformats.org/officeDocument/2006/relationships" xmlns:p="http://schemas.openxmlformats.org/presentationml/2006/main">
+  <p:cSld>
+    <p:spTree>
+      <p:nvGrpSpPr>
+        <p:cNvPr id="1" name=""/>
+        <p:cNvGrpSpPr/>
+        <p:nvPr/>
+      </p:nvGrpSpPr>
+      <p:grpSpPr>
+        <a:xfrm>
+          <a:off x="0" y="0"/>
+          <a:ext cx="0" cy="0"/>
+          <a:chOff x="0" y="0"/>
+          <a:chExt cx="0" cy="0"/>
+        </a:xfrm>
+      </p:grpSpPr>
+      <p:cxnSp>
+        <p:nvCxnSpPr>
+          <p:cNvPr id="5" name="Straight Arrow Connector 4">
+            <a:extLst>
+              <a:ext uri="{FF2B5EF4-FFF2-40B4-BE49-F238E27FC236}">
+                <a16:creationId xmlns:a16="http://schemas.microsoft.com/office/drawing/2014/main" id="{3165D564-760F-C86C-A424-A32583C29A58}"/>
+              </a:ext>
+            </a:extLst>
+          </p:cNvPr>
+          <p:cNvCxnSpPr/>
+          <p:nvPr/>
+        </p:nvCxnSpPr>
+        <p:spPr>
+          <a:xfrm flipV="1">
+            <a:off x="1088136" y="301752"/>
+            <a:ext cx="0" cy="5577840"/>
+          </a:xfrm>
+          <a:prstGeom prst="straightConnector1">
+            <a:avLst/>
+          </a:prstGeom>
+          <a:ln w="76200">
+            <a:tailEnd type="triangle"/>
+          </a:ln>
+        </p:spPr>
+        <p:style>
+          <a:lnRef idx="2">
+            <a:schemeClr val="accent1"/>
+          </a:lnRef>
+          <a:fillRef idx="0">
+            <a:schemeClr val="accent1"/>
+          </a:fillRef>
+          <a:effectRef idx="1">
+            <a:schemeClr val="accent1"/>
+          </a:effectRef>
+          <a:fontRef idx="minor">
+            <a:schemeClr val="tx1"/>
+          </a:fontRef>
+        </p:style>
+      </p:cxnSp>
+      <p:cxnSp>
+        <p:nvCxnSpPr>
+          <p:cNvPr id="6" name="Straight Arrow Connector 5">
+            <a:extLst>
+              <a:ext uri="{FF2B5EF4-FFF2-40B4-BE49-F238E27FC236}">
+                <a16:creationId xmlns:a16="http://schemas.microsoft.com/office/drawing/2014/main" id="{29D0C014-E233-FA34-6ADA-A1C326E969D7}"/>
+              </a:ext>
+            </a:extLst>
+          </p:cNvPr>
+          <p:cNvCxnSpPr>
+            <a:cxnSpLocks/>
+          </p:cNvCxnSpPr>
+          <p:nvPr/>
+        </p:nvCxnSpPr>
+        <p:spPr>
+          <a:xfrm>
+            <a:off x="1048512" y="5858256"/>
+            <a:ext cx="8333232" cy="0"/>
+          </a:xfrm>
+          <a:prstGeom prst="straightConnector1">
+            <a:avLst/>
+          </a:prstGeom>
+          <a:ln w="76200">
+            <a:headEnd type="none" w="med" len="med"/>
+            <a:tailEnd type="none" w="med" len="med"/>
+          </a:ln>
+        </p:spPr>
+        <p:style>
+          <a:lnRef idx="2">
+            <a:schemeClr val="accent1"/>
+          </a:lnRef>
+          <a:fillRef idx="0">
+            <a:schemeClr val="accent1"/>
+          </a:fillRef>
+          <a:effectRef idx="1">
+            <a:schemeClr val="accent1"/>
+          </a:effectRef>
+          <a:fontRef idx="minor">
+            <a:schemeClr val="tx1"/>
+          </a:fontRef>
+        </p:style>
+      </p:cxnSp>
+      <p:cxnSp>
+        <p:nvCxnSpPr>
+          <p:cNvPr id="9" name="Straight Connector 8">
+            <a:extLst>
+              <a:ext uri="{FF2B5EF4-FFF2-40B4-BE49-F238E27FC236}">
+                <a16:creationId xmlns:a16="http://schemas.microsoft.com/office/drawing/2014/main" id="{18830C68-2501-0A9F-6D5B-709EB446BA2B}"/>
+              </a:ext>
+            </a:extLst>
+          </p:cNvPr>
+          <p:cNvCxnSpPr/>
+          <p:nvPr/>
+        </p:nvCxnSpPr>
+        <p:spPr>
+          <a:xfrm>
+            <a:off x="1618488" y="4151376"/>
+            <a:ext cx="7370064" cy="0"/>
+          </a:xfrm>
+          <a:prstGeom prst="line">
+            <a:avLst/>
+          </a:prstGeom>
+          <a:ln w="38100"/>
+        </p:spPr>
+        <p:style>
+          <a:lnRef idx="2">
+            <a:schemeClr val="dk1"/>
+          </a:lnRef>
+          <a:fillRef idx="0">
+            <a:schemeClr val="dk1"/>
+          </a:fillRef>
+          <a:effectRef idx="1">
+            <a:schemeClr val="dk1"/>
+          </a:effectRef>
+          <a:fontRef idx="minor">
+            <a:schemeClr val="tx1"/>
+          </a:fontRef>
+        </p:style>
+      </p:cxnSp>
+      <p:cxnSp>
+        <p:nvCxnSpPr>
+          <p:cNvPr id="10" name="Straight Connector 9">
+            <a:extLst>
+              <a:ext uri="{FF2B5EF4-FFF2-40B4-BE49-F238E27FC236}">
+                <a16:creationId xmlns:a16="http://schemas.microsoft.com/office/drawing/2014/main" id="{54C2CE58-B1B8-B487-F0AC-A7739467FD20}"/>
+              </a:ext>
+            </a:extLst>
+          </p:cNvPr>
+          <p:cNvCxnSpPr/>
+          <p:nvPr/>
+        </p:nvCxnSpPr>
+        <p:spPr>
+          <a:xfrm>
+            <a:off x="1618488" y="1395984"/>
+            <a:ext cx="7370064" cy="0"/>
+          </a:xfrm>
+          <a:prstGeom prst="line">
+            <a:avLst/>
+          </a:prstGeom>
+          <a:ln w="38100"/>
+        </p:spPr>
+        <p:style>
+          <a:lnRef idx="2">
+            <a:schemeClr val="dk1"/>
+          </a:lnRef>
+          <a:fillRef idx="0">
+            <a:schemeClr val="dk1"/>
+          </a:fillRef>
+          <a:effectRef idx="1">
+            <a:schemeClr val="dk1"/>
+          </a:effectRef>
+          <a:fontRef idx="minor">
+            <a:schemeClr val="tx1"/>
+          </a:fontRef>
+        </p:style>
+      </p:cxnSp>
+    </p:spTree>
+    <p:extLst>
+      <p:ext uri="{BB962C8B-B14F-4D97-AF65-F5344CB8AC3E}">
+        <p14:creationId xmlns:p14="http://schemas.microsoft.com/office/powerpoint/2010/main" val="1809686048"/>
       </p:ext>
     </p:extLst>
   </p:cSld>
@@ -5682,4 +5945,10 @@
     </a:ext>
   </a:extLst>
 </a:theme>
+</file>
+
+<file path=docMetadata/LabelInfo.xml><?xml version="1.0" encoding="utf-8"?>
+<clbl:labelList xmlns:clbl="http://schemas.microsoft.com/office/2020/mipLabelMetadata">
+  <clbl:label id="{37c354b2-85b0-47f5-b222-07b48d774ee3}" enabled="0" method="" siteId="{37c354b2-85b0-47f5-b222-07b48d774ee3}" removed="1"/>
+</clbl:labelList>
 </file>
</xml_diff>